<commit_message>
chore(examples): replace smoke-test PPTX with Hong Kong committee register
Rewrite the four-page Quick Generate example in listed-company announcement
tone, Traditional Chinese first, and include a prepared evidence photo of
papers beside a laptop so the file is natively editable DrawingML with media.

Co-authored-by: Charliech <charleschtsoi@gmail.com>
</commit_message>
<xml_diff>
--- a/examples/ai_native_pptx_brief.pptx
+++ b/examples/ai_native_pptx_brief.pptx
@@ -112,7 +112,7 @@
 
 <file path=ppt/slideLayouts/slideLayout7.xml><?xml version="1.0" encoding="utf-8"?>
 <p:sldLayout xmlns:a="http://schemas.openxmlformats.org/drawingml/2006/main" xmlns:p="http://schemas.openxmlformats.org/presentationml/2006/main" type="blank" preserve="1">
-  <p:cSld name="ai_native_pptx_brief — Blank">
+  <p:cSld name="hk_native_pptx_brief — Blank">
     <p:spTree>
       <p:nvGrpSpPr>
         <p:cNvPr id="1" name=""/>
@@ -202,7 +202,7 @@
 
 <file path=ppt/slideMasters/slideMaster1.xml><?xml version="1.0" encoding="utf-8"?>
 <p:sldMaster xmlns:a="http://schemas.openxmlformats.org/drawingml/2006/main" xmlns:p="http://schemas.openxmlformats.org/presentationml/2006/main" xmlns:r="http://schemas.openxmlformats.org/officeDocument/2006/relationships">
-  <p:cSld name="ai_native_pptx_brief — Master">
+  <p:cSld name="hk_native_pptx_brief — Master">
     <p:bg>
       <p:bgRef idx="1001">
         <a:schemeClr val="bg1"/>
@@ -633,8 +633,8 @@
         </p:nvSpPr>
         <p:spPr>
           <a:xfrm>
-            <a:off x="914400" y="1790700"/>
-            <a:ext cx="76200" cy="2552700"/>
+            <a:off x="914400" y="1676400"/>
+            <a:ext cx="76200" cy="2667000"/>
           </a:xfrm>
           <a:prstGeom prst="rect">
             <a:avLst/>
@@ -655,10 +655,10 @@
         </p:nvGrpSpPr>
         <p:grpSpPr>
           <a:xfrm>
-            <a:off x="1213104" y="1022350"/>
-            <a:ext cx="2174860" cy="234696"/>
-            <a:chOff x="1213104" y="1022350"/>
-            <a:chExt cx="2174860" cy="234696"/>
+            <a:off x="1213104" y="965200"/>
+            <a:ext cx="1418368" cy="234696"/>
+            <a:chOff x="1213104" y="965200"/>
+            <a:chExt cx="1418368" cy="234696"/>
           </a:xfrm>
         </p:grpSpPr>
         <p:sp>
@@ -669,8 +669,8 @@
           </p:nvSpPr>
           <p:spPr>
             <a:xfrm>
-              <a:off x="1213104" y="1022350"/>
-              <a:ext cx="2174860" cy="234696"/>
+              <a:off x="1213104" y="965200"/>
+              <a:ext cx="1418368" cy="234696"/>
             </a:xfrm>
             <a:prstGeom prst="rect">
               <a:avLst/>
@@ -688,7 +688,7 @@
             <a:p>
               <a:pPr algn="l"/>
               <a:r>
-                <a:rPr lang="en-US" sz="1200" dirty="0">
+                <a:rPr lang="zh-HK" sz="1200" dirty="0">
                   <a:solidFill>
                     <a:srgbClr val="D5D0C8"/>
                   </a:solidFill>
@@ -696,7 +696,7 @@
                   <a:ea typeface="+mj-ea"/>
                   <a:cs typeface="+mj-cs"/>
                 </a:rPr>
-                <a:t>QUICK GENERATE | 8 MINUTES</a:t>
+                <a:t>委員會文件 · 八分鐘</a:t>
               </a:r>
             </a:p>
           </p:txBody>
@@ -710,10 +710,10 @@
         </p:nvGrpSpPr>
         <p:grpSpPr>
           <a:xfrm>
-            <a:off x="1200150" y="1917700"/>
-            <a:ext cx="5504974" cy="1447800"/>
-            <a:chOff x="1200150" y="1917700"/>
-            <a:chExt cx="5504974" cy="1447800"/>
+            <a:off x="1200150" y="1879600"/>
+            <a:ext cx="6972300" cy="1409700"/>
+            <a:chOff x="1200150" y="1879600"/>
+            <a:chExt cx="6972300" cy="1409700"/>
           </a:xfrm>
         </p:grpSpPr>
         <p:sp>
@@ -724,8 +724,8 @@
           </p:nvSpPr>
           <p:spPr>
             <a:xfrm>
-              <a:off x="1200150" y="1917700"/>
-              <a:ext cx="5504974" cy="1447800"/>
+              <a:off x="1200150" y="1879600"/>
+              <a:ext cx="6972300" cy="1409700"/>
             </a:xfrm>
             <a:prstGeom prst="rect">
               <a:avLst/>
@@ -743,7 +743,7 @@
             <a:p>
               <a:pPr algn="l">
                 <a:lnSpc>
-                  <a:spcPts val="5400"/>
+                  <a:spcPts val="5100"/>
                 </a:lnSpc>
               </a:pPr>
               <a:r>
@@ -755,28 +755,39 @@
                   <a:ea typeface="+mn-ea"/>
                   <a:cs typeface="+mn-cs"/>
                 </a:rPr>
-                <a:t>真正可改的 PowerPoint</a:t>
-              </a:r>
-              <a:br>
+                <a:t>建議以</a:t>
+              </a:r>
+              <a:r>
                 <a:rPr lang="zh-HK" sz="3900" b="1" dirty="0">
                   <a:solidFill>
-                    <a:srgbClr val="FFFFFF"/>
+                    <a:srgbClr val="B8860B"/>
                   </a:solidFill>
                   <a:latin typeface="+mn-lt"/>
                   <a:ea typeface="+mn-ea"/>
                   <a:cs typeface="+mn-cs"/>
                 </a:rPr>
-              </a:br>
-              <a:r>
+                <a:t>可編輯 PPTX</a:t>
+              </a:r>
+              <a:br>
                 <a:rPr lang="zh-HK" sz="3900" b="1" dirty="0">
                   <a:solidFill>
-                    <a:srgbClr val="FFFFFF"/>
+                    <a:srgbClr val="B8860B"/>
                   </a:solidFill>
                   <a:latin typeface="+mn-lt"/>
                   <a:ea typeface="+mn-ea"/>
                   <a:cs typeface="+mn-cs"/>
                 </a:rPr>
-                <a:t>不是幻燈片圖片</a:t>
+              </a:br>
+              <a:r>
+                <a:rPr lang="zh-HK" sz="3900" b="1" dirty="0">
+                  <a:solidFill>
+                    <a:srgbClr val="FFFFFF"/>
+                  </a:solidFill>
+                  <a:latin typeface="+mn-lt"/>
+                  <a:ea typeface="+mn-ea"/>
+                  <a:cs typeface="+mn-cs"/>
+                </a:rPr>
+                <a:t>作為本港委員會文件的交付標準</a:t>
               </a:r>
             </a:p>
           </p:txBody>
@@ -790,10 +801,10 @@
         </p:nvGrpSpPr>
         <p:grpSpPr>
           <a:xfrm>
-            <a:off x="1210818" y="3848100"/>
-            <a:ext cx="6248585" cy="322707"/>
-            <a:chOff x="1210818" y="3848100"/>
-            <a:chExt cx="6248585" cy="322707"/>
+            <a:off x="1210818" y="3771900"/>
+            <a:ext cx="5608012" cy="322707"/>
+            <a:chOff x="1210818" y="3771900"/>
+            <a:chExt cx="5608012" cy="322707"/>
           </a:xfrm>
         </p:grpSpPr>
         <p:sp>
@@ -804,8 +815,8 @@
           </p:nvSpPr>
           <p:spPr>
             <a:xfrm>
-              <a:off x="1210818" y="3848100"/>
-              <a:ext cx="6248585" cy="322707"/>
+              <a:off x="1210818" y="3771900"/>
+              <a:ext cx="5608012" cy="322707"/>
             </a:xfrm>
             <a:prstGeom prst="rect">
               <a:avLst/>
@@ -831,7 +842,7 @@
                   <a:ea typeface="+mj-ea"/>
                   <a:cs typeface="+mj-cs"/>
                 </a:rPr>
-                <a:t>A native PPTX from an AI agent - four pages, Traditional Chinese first</a:t>
+                <a:t>Committee papers should leave the room as an editable PPTX</a:t>
               </a:r>
             </a:p>
           </p:txBody>
@@ -845,10 +856,10 @@
         </p:nvGrpSpPr>
         <p:grpSpPr>
           <a:xfrm>
-            <a:off x="1213104" y="6019800"/>
-            <a:ext cx="2717926" cy="234696"/>
-            <a:chOff x="1213104" y="6019800"/>
-            <a:chExt cx="2717926" cy="234696"/>
+            <a:off x="1213104" y="5994400"/>
+            <a:ext cx="2628102" cy="234696"/>
+            <a:chOff x="1213104" y="5994400"/>
+            <a:chExt cx="2628102" cy="234696"/>
           </a:xfrm>
         </p:grpSpPr>
         <p:sp>
@@ -859,8 +870,8 @@
           </p:nvSpPr>
           <p:spPr>
             <a:xfrm>
-              <a:off x="1213104" y="6019800"/>
-              <a:ext cx="2717926" cy="234696"/>
+              <a:off x="1213104" y="5994400"/>
+              <a:ext cx="2628102" cy="234696"/>
             </a:xfrm>
             <a:prstGeom prst="rect">
               <a:avLst/>
@@ -882,11 +893,11 @@
                   <a:solidFill>
                     <a:srgbClr val="D5D0C8"/>
                   </a:solidFill>
-                  <a:latin typeface="+mn-lt"/>
-                  <a:ea typeface="+mn-ea"/>
-                  <a:cs typeface="+mn-cs"/>
-                </a:rPr>
-                <a:t>Harbour Professional | 2026-10-28</a:t>
+                  <a:latin typeface="+mj-lt"/>
+                  <a:ea typeface="+mj-ea"/>
+                  <a:cs typeface="+mj-cs"/>
+                </a:rPr>
+                <a:t>Harbour Professional · 28 October 2026</a:t>
               </a:r>
             </a:p>
           </p:txBody>
@@ -958,10 +969,10 @@
         </p:nvGrpSpPr>
         <p:grpSpPr>
           <a:xfrm>
-            <a:off x="899160" y="622300"/>
-            <a:ext cx="8511540" cy="957707"/>
-            <a:chOff x="899160" y="622300"/>
-            <a:chExt cx="8511540" cy="957707"/>
+            <a:off x="746760" y="508000"/>
+            <a:ext cx="3840480" cy="1791970"/>
+            <a:chOff x="746760" y="508000"/>
+            <a:chExt cx="3840480" cy="1791970"/>
           </a:xfrm>
         </p:grpSpPr>
         <p:sp>
@@ -972,205 +983,8 @@
           </p:nvSpPr>
           <p:spPr>
             <a:xfrm>
-              <a:off x="899160" y="622300"/>
-              <a:ext cx="8511540" cy="586740"/>
-            </a:xfrm>
-            <a:prstGeom prst="rect">
-              <a:avLst/>
-            </a:prstGeom>
-            <a:noFill/>
-            <a:ln>
-              <a:noFill/>
-            </a:ln>
-          </p:spPr>
-          <p:txBody>
-            <a:bodyPr wrap="none" lIns="0" tIns="0" rIns="0" bIns="0" anchor="t" anchorCtr="0">
-              <a:spAutoFit/>
-            </a:bodyPr>
-            <a:lstStyle/>
-            <a:p>
-              <a:pPr algn="l"/>
-              <a:r>
-                <a:rPr lang="zh-HK" sz="3000" b="1" dirty="0">
-                  <a:solidFill>
-                    <a:srgbClr val="123B5C"/>
-                  </a:solidFill>
-                  <a:latin typeface="+mn-lt"/>
-                  <a:ea typeface="+mn-ea"/>
-                  <a:cs typeface="+mn-cs"/>
-                </a:rPr>
-                <a:t>香港簡報要結論先行、兩文層級、可帶走的檔案</a:t>
-              </a:r>
-            </a:p>
-          </p:txBody>
-        </p:sp>
-        <p:sp>
-          <p:nvSpPr>
-            <p:cNvPr id="4" name="TextBox 4"/>
-            <p:cNvSpPr txBox="1"/>
-            <p:nvPr/>
-          </p:nvSpPr>
-          <p:spPr>
-            <a:xfrm>
-              <a:off x="906018" y="1257300"/>
-              <a:ext cx="7723506" cy="322707"/>
-            </a:xfrm>
-            <a:prstGeom prst="rect">
-              <a:avLst/>
-            </a:prstGeom>
-            <a:noFill/>
-            <a:ln>
-              <a:noFill/>
-            </a:ln>
-          </p:spPr>
-          <p:txBody>
-            <a:bodyPr wrap="none" lIns="0" tIns="0" rIns="0" bIns="0" anchor="t" anchorCtr="0">
-              <a:spAutoFit/>
-            </a:bodyPr>
-            <a:lstStyle/>
-            <a:p>
-              <a:pPr algn="l"/>
-              <a:r>
-                <a:rPr lang="en-US" sz="1650" dirty="0">
-                  <a:solidFill>
-                    <a:srgbClr val="5C6570"/>
-                  </a:solidFill>
-                  <a:latin typeface="+mj-lt"/>
-                  <a:ea typeface="+mj-ea"/>
-                  <a:cs typeface="+mj-cs"/>
-                </a:rPr>
-                <a:t>HK rooms want the answer first, one language in the lead, and a file they can still edit</a:t>
-              </a:r>
-            </a:p>
-          </p:txBody>
-        </p:sp>
-      </p:grpSp>
-      <p:grpSp>
-        <p:nvGrpSpPr>
-          <p:cNvPr id="10" name="sit-point-1"/>
-          <p:cNvGrpSpPr/>
-          <p:nvPr/>
-        </p:nvGrpSpPr>
-        <p:grpSpPr>
-          <a:xfrm>
-            <a:off x="903732" y="2286000"/>
-            <a:ext cx="1888236" cy="2715768"/>
-            <a:chOff x="903732" y="2286000"/>
-            <a:chExt cx="1888236" cy="2715768"/>
-          </a:xfrm>
-        </p:grpSpPr>
-        <p:sp>
-          <p:nvSpPr>
-            <p:cNvPr id="6" name="Rectangle 6"/>
-            <p:cNvSpPr/>
-            <p:nvPr/>
-          </p:nvSpPr>
-          <p:spPr>
-            <a:xfrm>
-              <a:off x="914400" y="2286000"/>
-              <a:ext cx="76200" cy="457200"/>
-            </a:xfrm>
-            <a:prstGeom prst="rect">
-              <a:avLst/>
-            </a:prstGeom>
-            <a:solidFill>
-              <a:srgbClr val="B8860B"/>
-            </a:solidFill>
-            <a:ln>
-              <a:noFill/>
-            </a:ln>
-          </p:spPr>
-        </p:sp>
-        <p:sp>
-          <p:nvSpPr>
-            <p:cNvPr id="7" name="TextBox 7"/>
-            <p:cNvSpPr txBox="1"/>
-            <p:nvPr/>
-          </p:nvSpPr>
-          <p:spPr>
-            <a:xfrm>
-              <a:off x="1132332" y="2374900"/>
-              <a:ext cx="1152144" cy="410718"/>
-            </a:xfrm>
-            <a:prstGeom prst="rect">
-              <a:avLst/>
-            </a:prstGeom>
-            <a:noFill/>
-            <a:ln>
-              <a:noFill/>
-            </a:ln>
-          </p:spPr>
-          <p:txBody>
-            <a:bodyPr wrap="none" lIns="0" tIns="0" rIns="0" bIns="0" anchor="t" anchorCtr="0">
-              <a:spAutoFit/>
-            </a:bodyPr>
-            <a:lstStyle/>
-            <a:p>
-              <a:pPr algn="l"/>
-              <a:r>
-                <a:rPr lang="zh-HK" sz="2100" b="1" dirty="0">
-                  <a:solidFill>
-                    <a:srgbClr val="123B5C"/>
-                  </a:solidFill>
-                  <a:latin typeface="+mn-lt"/>
-                  <a:ea typeface="+mn-ea"/>
-                  <a:cs typeface="+mn-cs"/>
-                </a:rPr>
-                <a:t>結論先行</a:t>
-              </a:r>
-            </a:p>
-          </p:txBody>
-        </p:sp>
-        <p:sp>
-          <p:nvSpPr>
-            <p:cNvPr id="8" name="TextBox 8"/>
-            <p:cNvSpPr txBox="1"/>
-            <p:nvPr/>
-          </p:nvSpPr>
-          <p:spPr>
-            <a:xfrm>
-              <a:off x="906018" y="2971800"/>
-              <a:ext cx="1590246" cy="322707"/>
-            </a:xfrm>
-            <a:prstGeom prst="rect">
-              <a:avLst/>
-            </a:prstGeom>
-            <a:noFill/>
-            <a:ln>
-              <a:noFill/>
-            </a:ln>
-          </p:spPr>
-          <p:txBody>
-            <a:bodyPr wrap="none" lIns="0" tIns="0" rIns="0" bIns="0" anchor="t" anchorCtr="0">
-              <a:spAutoFit/>
-            </a:bodyPr>
-            <a:lstStyle/>
-            <a:p>
-              <a:pPr algn="l"/>
-              <a:r>
-                <a:rPr lang="en-US" sz="1650" dirty="0">
-                  <a:solidFill>
-                    <a:srgbClr val="1F6A7A"/>
-                  </a:solidFill>
-                  <a:latin typeface="+mj-lt"/>
-                  <a:ea typeface="+mj-ea"/>
-                  <a:cs typeface="+mj-cs"/>
-                </a:rPr>
-                <a:t>Key message first</a:t>
-              </a:r>
-            </a:p>
-          </p:txBody>
-        </p:sp>
-        <p:sp>
-          <p:nvSpPr>
-            <p:cNvPr id="9" name="TextBox 9"/>
-            <p:cNvSpPr txBox="1"/>
-            <p:nvPr/>
-          </p:nvSpPr>
-          <p:spPr>
-            <a:xfrm>
-              <a:off x="903732" y="3390900"/>
-              <a:ext cx="1888236" cy="1610868"/>
+              <a:off x="746760" y="508000"/>
+              <a:ext cx="3840480" cy="1082040"/>
             </a:xfrm>
             <a:prstGeom prst="rect">
               <a:avLst/>
@@ -1188,24 +1002,24 @@
             <a:p>
               <a:pPr algn="l">
                 <a:lnSpc>
-                  <a:spcPts val="3150"/>
+                  <a:spcPts val="3900"/>
                 </a:lnSpc>
               </a:pPr>
               <a:r>
-                <a:rPr lang="zh-HK" sz="2100" dirty="0">
-                  <a:solidFill>
-                    <a:srgbClr val="1A1F24"/>
+                <a:rPr lang="zh-HK" sz="3000" b="1" dirty="0">
+                  <a:solidFill>
+                    <a:srgbClr val="123B5C"/>
                   </a:solidFill>
                   <a:latin typeface="+mn-lt"/>
                   <a:ea typeface="+mn-ea"/>
                   <a:cs typeface="+mn-cs"/>
                 </a:rPr>
-                <a:t>先給答案，再用</a:t>
+                <a:t>螢幕截圖式簡報在會後</a:t>
               </a:r>
               <a:br>
-                <a:rPr lang="zh-HK" sz="2100" dirty="0">
-                  <a:solidFill>
-                    <a:srgbClr val="1A1F24"/>
+                <a:rPr lang="zh-HK" sz="3000" b="1" dirty="0">
+                  <a:solidFill>
+                    <a:srgbClr val="123B5C"/>
                   </a:solidFill>
                   <a:latin typeface="+mn-lt"/>
                   <a:ea typeface="+mn-ea"/>
@@ -1213,188 +1027,29 @@
                 </a:rPr>
               </a:br>
               <a:r>
-                <a:rPr lang="zh-HK" sz="2100" dirty="0">
-                  <a:solidFill>
-                    <a:srgbClr val="1A1F24"/>
+                <a:rPr lang="zh-HK" sz="3000" b="1" dirty="0">
+                  <a:solidFill>
+                    <a:srgbClr val="123B5C"/>
                   </a:solidFill>
                   <a:latin typeface="+mn-lt"/>
                   <a:ea typeface="+mn-ea"/>
                   <a:cs typeface="+mn-cs"/>
                 </a:rPr>
-                <a:t>一至三個支撐。</a:t>
-              </a:r>
-              <a:br>
-                <a:rPr lang="zh-HK" sz="2100" dirty="0">
-                  <a:solidFill>
-                    <a:srgbClr val="1A1F24"/>
-                  </a:solidFill>
-                  <a:latin typeface="+mn-lt"/>
-                  <a:ea typeface="+mn-ea"/>
-                  <a:cs typeface="+mn-cs"/>
-                </a:rPr>
-              </a:br>
-              <a:r>
-                <a:rPr lang="zh-HK" sz="2100" dirty="0">
-                  <a:solidFill>
-                    <a:srgbClr val="1A1F24"/>
-                  </a:solidFill>
-                  <a:latin typeface="+mn-lt"/>
-                  <a:ea typeface="+mn-ea"/>
-                  <a:cs typeface="+mn-cs"/>
-                </a:rPr>
-                <a:t>長鋪墊在港式</a:t>
-              </a:r>
-              <a:br>
-                <a:rPr lang="zh-HK" sz="2100" dirty="0">
-                  <a:solidFill>
-                    <a:srgbClr val="1A1F24"/>
-                  </a:solidFill>
-                  <a:latin typeface="+mn-lt"/>
-                  <a:ea typeface="+mn-ea"/>
-                  <a:cs typeface="+mn-cs"/>
-                </a:rPr>
-              </a:br>
-              <a:r>
-                <a:rPr lang="zh-HK" sz="2100" dirty="0">
-                  <a:solidFill>
-                    <a:srgbClr val="1A1F24"/>
-                  </a:solidFill>
-                  <a:latin typeface="+mn-lt"/>
-                  <a:ea typeface="+mn-ea"/>
-                  <a:cs typeface="+mn-cs"/>
-                </a:rPr>
-                <a:t>會議室是延遲。</a:t>
+                <a:t>無法按委員會要求修訂</a:t>
               </a:r>
             </a:p>
           </p:txBody>
         </p:sp>
-      </p:grpSp>
-      <p:grpSp>
-        <p:nvGrpSpPr>
-          <p:cNvPr id="15" name="sit-point-2"/>
-          <p:cNvGrpSpPr/>
-          <p:nvPr/>
-        </p:nvGrpSpPr>
-        <p:grpSpPr>
-          <a:xfrm>
-            <a:off x="4466082" y="2286000"/>
-            <a:ext cx="2421636" cy="2715768"/>
-            <a:chOff x="4466082" y="2286000"/>
-            <a:chExt cx="2421636" cy="2715768"/>
-          </a:xfrm>
-        </p:grpSpPr>
         <p:sp>
           <p:nvSpPr>
-            <p:cNvPr id="11" name="Rectangle 11"/>
-            <p:cNvSpPr/>
-            <p:nvPr/>
-          </p:nvSpPr>
-          <p:spPr>
-            <a:xfrm>
-              <a:off x="4476750" y="2286000"/>
-              <a:ext cx="76200" cy="457200"/>
-            </a:xfrm>
-            <a:prstGeom prst="rect">
-              <a:avLst/>
-            </a:prstGeom>
-            <a:solidFill>
-              <a:srgbClr val="B8860B"/>
-            </a:solidFill>
-            <a:ln>
-              <a:noFill/>
-            </a:ln>
-          </p:spPr>
-        </p:sp>
-        <p:sp>
-          <p:nvSpPr>
-            <p:cNvPr id="12" name="TextBox 12"/>
+            <p:cNvPr id="4" name="TextBox 4"/>
             <p:cNvSpPr txBox="1"/>
             <p:nvPr/>
           </p:nvSpPr>
           <p:spPr>
             <a:xfrm>
-              <a:off x="4694682" y="2374900"/>
-              <a:ext cx="1717548" cy="410718"/>
-            </a:xfrm>
-            <a:prstGeom prst="rect">
-              <a:avLst/>
-            </a:prstGeom>
-            <a:noFill/>
-            <a:ln>
-              <a:noFill/>
-            </a:ln>
-          </p:spPr>
-          <p:txBody>
-            <a:bodyPr wrap="none" lIns="0" tIns="0" rIns="0" bIns="0" anchor="t" anchorCtr="0">
-              <a:spAutoFit/>
-            </a:bodyPr>
-            <a:lstStyle/>
-            <a:p>
-              <a:pPr algn="l"/>
-              <a:r>
-                <a:rPr lang="zh-HK" sz="2100" b="1" dirty="0">
-                  <a:solidFill>
-                    <a:srgbClr val="123B5C"/>
-                  </a:solidFill>
-                  <a:latin typeface="+mn-lt"/>
-                  <a:ea typeface="+mn-ea"/>
-                  <a:cs typeface="+mn-cs"/>
-                </a:rPr>
-                <a:t>一種語言主導</a:t>
-              </a:r>
-            </a:p>
-          </p:txBody>
-        </p:sp>
-        <p:sp>
-          <p:nvSpPr>
-            <p:cNvPr id="13" name="TextBox 13"/>
-            <p:cNvSpPr txBox="1"/>
-            <p:nvPr/>
-          </p:nvSpPr>
-          <p:spPr>
-            <a:xfrm>
-              <a:off x="4468368" y="2971800"/>
-              <a:ext cx="1786036" cy="322707"/>
-            </a:xfrm>
-            <a:prstGeom prst="rect">
-              <a:avLst/>
-            </a:prstGeom>
-            <a:noFill/>
-            <a:ln>
-              <a:noFill/>
-            </a:ln>
-          </p:spPr>
-          <p:txBody>
-            <a:bodyPr wrap="none" lIns="0" tIns="0" rIns="0" bIns="0" anchor="t" anchorCtr="0">
-              <a:spAutoFit/>
-            </a:bodyPr>
-            <a:lstStyle/>
-            <a:p>
-              <a:pPr algn="l"/>
-              <a:r>
-                <a:rPr lang="en-US" sz="1650" dirty="0">
-                  <a:solidFill>
-                    <a:srgbClr val="1F6A7A"/>
-                  </a:solidFill>
-                  <a:latin typeface="+mj-lt"/>
-                  <a:ea typeface="+mj-ea"/>
-                  <a:cs typeface="+mj-cs"/>
-                </a:rPr>
-                <a:t>One language leads</a:t>
-              </a:r>
-            </a:p>
-          </p:txBody>
-        </p:sp>
-        <p:sp>
-          <p:nvSpPr>
-            <p:cNvPr id="14" name="TextBox 14"/>
-            <p:cNvSpPr txBox="1"/>
-            <p:nvPr/>
-          </p:nvSpPr>
-          <p:spPr>
-            <a:xfrm>
-              <a:off x="4466082" y="3390900"/>
-              <a:ext cx="2421636" cy="1610868"/>
+              <a:off x="754380" y="1739900"/>
+              <a:ext cx="3285096" cy="560070"/>
             </a:xfrm>
             <a:prstGeom prst="rect">
               <a:avLst/>
@@ -1412,82 +1067,40 @@
             <a:p>
               <a:pPr algn="l">
                 <a:lnSpc>
-                  <a:spcPts val="3150"/>
+                  <a:spcPts val="2100"/>
                 </a:lnSpc>
               </a:pPr>
               <a:r>
-                <a:rPr lang="zh-HK" sz="2100" dirty="0">
-                  <a:solidFill>
-                    <a:srgbClr val="1A1F24"/>
-                  </a:solidFill>
-                  <a:latin typeface="+mn-lt"/>
-                  <a:ea typeface="+mn-ea"/>
-                  <a:cs typeface="+mn-cs"/>
-                </a:rPr>
-                <a:t>繁體中文扛主句，</a:t>
+                <a:rPr lang="en-US" sz="1500" dirty="0">
+                  <a:solidFill>
+                    <a:srgbClr val="5C6570"/>
+                  </a:solidFill>
+                  <a:latin typeface="+mj-lt"/>
+                  <a:ea typeface="+mj-ea"/>
+                  <a:cs typeface="+mj-cs"/>
+                </a:rPr>
+                <a:t>A screenshot cannot take the committee's</a:t>
               </a:r>
               <a:br>
-                <a:rPr lang="zh-HK" sz="2100" dirty="0">
-                  <a:solidFill>
-                    <a:srgbClr val="1A1F24"/>
-                  </a:solidFill>
-                  <a:latin typeface="+mn-lt"/>
-                  <a:ea typeface="+mn-ea"/>
-                  <a:cs typeface="+mn-cs"/>
+                <a:rPr lang="en-US" sz="1500" dirty="0">
+                  <a:solidFill>
+                    <a:srgbClr val="5C6570"/>
+                  </a:solidFill>
+                  <a:latin typeface="+mj-lt"/>
+                  <a:ea typeface="+mj-ea"/>
+                  <a:cs typeface="+mj-cs"/>
                 </a:rPr>
               </a:br>
               <a:r>
-                <a:rPr lang="zh-HK" sz="2100" dirty="0">
-                  <a:solidFill>
-                    <a:srgbClr val="1A1F24"/>
-                  </a:solidFill>
-                  <a:latin typeface="+mn-lt"/>
-                  <a:ea typeface="+mn-ea"/>
-                  <a:cs typeface="+mn-cs"/>
-                </a:rPr>
-                <a:t>英文做較小的副標。</a:t>
-              </a:r>
-              <a:br>
-                <a:rPr lang="zh-HK" sz="2100" dirty="0">
-                  <a:solidFill>
-                    <a:srgbClr val="1A1F24"/>
-                  </a:solidFill>
-                  <a:latin typeface="+mn-lt"/>
-                  <a:ea typeface="+mn-ea"/>
-                  <a:cs typeface="+mn-cs"/>
-                </a:rPr>
-              </a:br>
-              <a:r>
-                <a:rPr lang="zh-HK" sz="2100" dirty="0">
-                  <a:solidFill>
-                    <a:srgbClr val="1A1F24"/>
-                  </a:solidFill>
-                  <a:latin typeface="+mn-lt"/>
-                  <a:ea typeface="+mn-ea"/>
-                  <a:cs typeface="+mn-cs"/>
-                </a:rPr>
-                <a:t>不要左右各半的</a:t>
-              </a:r>
-              <a:br>
-                <a:rPr lang="zh-HK" sz="2100" dirty="0">
-                  <a:solidFill>
-                    <a:srgbClr val="1A1F24"/>
-                  </a:solidFill>
-                  <a:latin typeface="+mn-lt"/>
-                  <a:ea typeface="+mn-ea"/>
-                  <a:cs typeface="+mn-cs"/>
-                </a:rPr>
-              </a:br>
-              <a:r>
-                <a:rPr lang="zh-HK" sz="2100" dirty="0">
-                  <a:solidFill>
-                    <a:srgbClr val="1A1F24"/>
-                  </a:solidFill>
-                  <a:latin typeface="+mn-lt"/>
-                  <a:ea typeface="+mn-ea"/>
-                  <a:cs typeface="+mn-cs"/>
-                </a:rPr>
-                <a:t>翻譯欄。</a:t>
+                <a:rPr lang="en-US" sz="1500" dirty="0">
+                  <a:solidFill>
+                    <a:srgbClr val="5C6570"/>
+                  </a:solidFill>
+                  <a:latin typeface="+mj-lt"/>
+                  <a:ea typeface="+mj-ea"/>
+                  <a:cs typeface="+mj-cs"/>
+                </a:rPr>
+                <a:t>amendments after the meeting</a:t>
               </a:r>
             </a:p>
           </p:txBody>
@@ -1495,130 +1108,28 @@
       </p:grpSp>
       <p:grpSp>
         <p:nvGrpSpPr>
-          <p:cNvPr id="20" name="sit-point-3"/>
+          <p:cNvPr id="7" name="sit-body"/>
           <p:cNvGrpSpPr/>
           <p:nvPr/>
         </p:nvGrpSpPr>
         <p:grpSpPr>
           <a:xfrm>
-            <a:off x="8028432" y="2286000"/>
-            <a:ext cx="2261616" cy="2315718"/>
-            <a:chOff x="8028432" y="2286000"/>
-            <a:chExt cx="2261616" cy="2315718"/>
+            <a:off x="752856" y="2616200"/>
+            <a:ext cx="3001518" cy="1437894"/>
+            <a:chOff x="752856" y="2616200"/>
+            <a:chExt cx="3001518" cy="1437894"/>
           </a:xfrm>
         </p:grpSpPr>
         <p:sp>
           <p:nvSpPr>
-            <p:cNvPr id="16" name="Rectangle 16"/>
-            <p:cNvSpPr/>
-            <p:nvPr/>
-          </p:nvSpPr>
-          <p:spPr>
-            <a:xfrm>
-              <a:off x="8039100" y="2286000"/>
-              <a:ext cx="76200" cy="457200"/>
-            </a:xfrm>
-            <a:prstGeom prst="rect">
-              <a:avLst/>
-            </a:prstGeom>
-            <a:solidFill>
-              <a:srgbClr val="B8860B"/>
-            </a:solidFill>
-            <a:ln>
-              <a:noFill/>
-            </a:ln>
-          </p:spPr>
-        </p:sp>
-        <p:sp>
-          <p:nvSpPr>
-            <p:cNvPr id="17" name="TextBox 17"/>
+            <p:cNvPr id="6" name="TextBox 6"/>
             <p:cNvSpPr txBox="1"/>
             <p:nvPr/>
           </p:nvSpPr>
           <p:spPr>
             <a:xfrm>
-              <a:off x="8257032" y="2374900"/>
-              <a:ext cx="1152144" cy="410718"/>
-            </a:xfrm>
-            <a:prstGeom prst="rect">
-              <a:avLst/>
-            </a:prstGeom>
-            <a:noFill/>
-            <a:ln>
-              <a:noFill/>
-            </a:ln>
-          </p:spPr>
-          <p:txBody>
-            <a:bodyPr wrap="none" lIns="0" tIns="0" rIns="0" bIns="0" anchor="t" anchorCtr="0">
-              <a:spAutoFit/>
-            </a:bodyPr>
-            <a:lstStyle/>
-            <a:p>
-              <a:pPr algn="l"/>
-              <a:r>
-                <a:rPr lang="zh-HK" sz="2100" b="1" dirty="0">
-                  <a:solidFill>
-                    <a:srgbClr val="123B5C"/>
-                  </a:solidFill>
-                  <a:latin typeface="+mn-lt"/>
-                  <a:ea typeface="+mn-ea"/>
-                  <a:cs typeface="+mn-cs"/>
-                </a:rPr>
-                <a:t>原生可改</a:t>
-              </a:r>
-            </a:p>
-          </p:txBody>
-        </p:sp>
-        <p:sp>
-          <p:nvSpPr>
-            <p:cNvPr id="18" name="TextBox 18"/>
-            <p:cNvSpPr txBox="1"/>
-            <p:nvPr/>
-          </p:nvSpPr>
-          <p:spPr>
-            <a:xfrm>
-              <a:off x="8030718" y="2971800"/>
-              <a:ext cx="1786137" cy="322707"/>
-            </a:xfrm>
-            <a:prstGeom prst="rect">
-              <a:avLst/>
-            </a:prstGeom>
-            <a:noFill/>
-            <a:ln>
-              <a:noFill/>
-            </a:ln>
-          </p:spPr>
-          <p:txBody>
-            <a:bodyPr wrap="none" lIns="0" tIns="0" rIns="0" bIns="0" anchor="t" anchorCtr="0">
-              <a:spAutoFit/>
-            </a:bodyPr>
-            <a:lstStyle/>
-            <a:p>
-              <a:pPr algn="l"/>
-              <a:r>
-                <a:rPr lang="en-US" sz="1650" dirty="0">
-                  <a:solidFill>
-                    <a:srgbClr val="1F6A7A"/>
-                  </a:solidFill>
-                  <a:latin typeface="+mj-lt"/>
-                  <a:ea typeface="+mj-ea"/>
-                  <a:cs typeface="+mj-cs"/>
-                </a:rPr>
-                <a:t>Native and editable</a:t>
-              </a:r>
-            </a:p>
-          </p:txBody>
-        </p:sp>
-        <p:sp>
-          <p:nvSpPr>
-            <p:cNvPr id="19" name="TextBox 19"/>
-            <p:cNvSpPr txBox="1"/>
-            <p:nvPr/>
-          </p:nvSpPr>
-          <p:spPr>
-            <a:xfrm>
-              <a:off x="8028432" y="3390900"/>
-              <a:ext cx="2261616" cy="1210818"/>
+              <a:off x="752856" y="2616200"/>
+              <a:ext cx="3001518" cy="1437894"/>
             </a:xfrm>
             <a:prstGeom prst="rect">
               <a:avLst/>
@@ -1636,11 +1147,11 @@
             <a:p>
               <a:pPr algn="l">
                 <a:lnSpc>
-                  <a:spcPts val="3150"/>
+                  <a:spcPts val="2850"/>
                 </a:lnSpc>
               </a:pPr>
               <a:r>
-                <a:rPr lang="zh-HK" sz="2100" dirty="0">
+                <a:rPr lang="zh-HK" sz="1800" dirty="0">
                   <a:solidFill>
                     <a:srgbClr val="1A1F24"/>
                   </a:solidFill>
@@ -1648,10 +1159,10 @@
                   <a:ea typeface="+mn-ea"/>
                   <a:cs typeface="+mn-cs"/>
                 </a:rPr>
-                <a:t>要的是 DrawingML</a:t>
+                <a:t>會後秘書處須按委員意見</a:t>
               </a:r>
               <a:br>
-                <a:rPr lang="zh-HK" sz="2100" dirty="0">
+                <a:rPr lang="zh-HK" sz="1800" dirty="0">
                   <a:solidFill>
                     <a:srgbClr val="1A1F24"/>
                   </a:solidFill>
@@ -1661,7 +1172,7 @@
                 </a:rPr>
               </a:br>
               <a:r>
-                <a:rPr lang="zh-HK" sz="2100" dirty="0">
+                <a:rPr lang="zh-HK" sz="1800" dirty="0">
                   <a:solidFill>
                     <a:srgbClr val="1A1F24"/>
                   </a:solidFill>
@@ -1669,10 +1180,10 @@
                   <a:ea typeface="+mn-ea"/>
                   <a:cs typeface="+mn-cs"/>
                 </a:rPr>
-                <a:t>形狀與文字，不是</a:t>
+                <a:t>改字、改圖、改排序。</a:t>
               </a:r>
               <a:br>
-                <a:rPr lang="zh-HK" sz="2100" dirty="0">
+                <a:rPr lang="zh-HK" sz="1800" dirty="0">
                   <a:solidFill>
                     <a:srgbClr val="1A1F24"/>
                   </a:solidFill>
@@ -1682,7 +1193,7 @@
                 </a:rPr>
               </a:br>
               <a:r>
-                <a:rPr lang="zh-HK" sz="2100" dirty="0">
+                <a:rPr lang="zh-HK" sz="1800" dirty="0">
                   <a:solidFill>
                     <a:srgbClr val="1A1F24"/>
                   </a:solidFill>
@@ -1690,22 +1201,138 @@
                   <a:ea typeface="+mn-ea"/>
                   <a:cs typeface="+mn-cs"/>
                 </a:rPr>
-                <a:t>一張全頁截圖。</a:t>
+                <a:t>截圖檔只能重做，</a:t>
+              </a:r>
+              <a:br>
+                <a:rPr lang="zh-HK" sz="1800" dirty="0">
+                  <a:solidFill>
+                    <a:srgbClr val="1A1F24"/>
+                  </a:solidFill>
+                  <a:latin typeface="+mn-lt"/>
+                  <a:ea typeface="+mn-ea"/>
+                  <a:cs typeface="+mn-cs"/>
+                </a:rPr>
+              </a:br>
+              <a:r>
+                <a:rPr lang="zh-HK" sz="1800" dirty="0">
+                  <a:solidFill>
+                    <a:srgbClr val="1A1F24"/>
+                  </a:solidFill>
+                  <a:latin typeface="+mn-lt"/>
+                  <a:ea typeface="+mn-ea"/>
+                  <a:cs typeface="+mn-cs"/>
+                </a:rPr>
+                <a:t>不能在 PowerPoint 內修訂。</a:t>
               </a:r>
             </a:p>
           </p:txBody>
         </p:sp>
       </p:grpSp>
+      <p:grpSp>
+        <p:nvGrpSpPr>
+          <p:cNvPr id="9" name="sit-takeaway"/>
+          <p:cNvGrpSpPr/>
+          <p:nvPr/>
+        </p:nvGrpSpPr>
+        <p:grpSpPr>
+          <a:xfrm>
+            <a:off x="755904" y="4914900"/>
+            <a:ext cx="2919984" cy="234696"/>
+            <a:chOff x="755904" y="4914900"/>
+            <a:chExt cx="2919984" cy="234696"/>
+          </a:xfrm>
+        </p:grpSpPr>
+        <p:sp>
+          <p:nvSpPr>
+            <p:cNvPr id="8" name="TextBox 8"/>
+            <p:cNvSpPr txBox="1"/>
+            <p:nvPr/>
+          </p:nvSpPr>
+          <p:spPr>
+            <a:xfrm>
+              <a:off x="755904" y="4914900"/>
+              <a:ext cx="2919984" cy="234696"/>
+            </a:xfrm>
+            <a:prstGeom prst="rect">
+              <a:avLst/>
+            </a:prstGeom>
+            <a:noFill/>
+            <a:ln>
+              <a:noFill/>
+            </a:ln>
+          </p:spPr>
+          <p:txBody>
+            <a:bodyPr wrap="none" lIns="0" tIns="0" rIns="0" bIns="0" anchor="t" anchorCtr="0">
+              <a:spAutoFit/>
+            </a:bodyPr>
+            <a:lstStyle/>
+            <a:p>
+              <a:pPr algn="l"/>
+              <a:r>
+                <a:rPr lang="zh-HK" sz="1200" dirty="0">
+                  <a:solidFill>
+                    <a:srgbClr val="B8860B"/>
+                  </a:solidFill>
+                  <a:latin typeface="+mn-lt"/>
+                  <a:ea typeface="+mn-ea"/>
+                  <a:cs typeface="+mn-cs"/>
+                </a:rPr>
+                <a:t>會後須修訂的是文字與形狀，不是截圖。</a:t>
+              </a:r>
+            </a:p>
+          </p:txBody>
+        </p:sp>
+      </p:grpSp>
+      <p:grpSp>
+        <p:nvGrpSpPr>
+          <p:cNvPr id="11" name="sit-photo"/>
+          <p:cNvGrpSpPr/>
+          <p:nvPr/>
+        </p:nvGrpSpPr>
+        <p:grpSpPr>
+          <a:xfrm>
+            <a:off x="5334000" y="0"/>
+            <a:ext cx="6858000" cy="6858000"/>
+            <a:chOff x="5334000" y="0"/>
+            <a:chExt cx="6858000" cy="6858000"/>
+          </a:xfrm>
+        </p:grpSpPr>
+        <p:pic>
+          <p:nvPicPr>
+            <p:cNvPr id="10" name="Image 10"/>
+            <p:cNvPicPr>
+              <a:picLocks noChangeAspect="1"/>
+            </p:cNvPicPr>
+            <p:nvPr/>
+          </p:nvPicPr>
+          <p:blipFill>
+            <a:blip r:embed="rId2"/>
+            <a:srcRect l="33333" t="0" r="0" b="0"/>
+            <a:stretch>
+              <a:fillRect/>
+            </a:stretch>
+          </p:blipFill>
+          <p:spPr>
+            <a:xfrm>
+              <a:off x="5334000" y="0"/>
+              <a:ext cx="6858000" cy="6858000"/>
+            </a:xfrm>
+            <a:prstGeom prst="rect">
+              <a:avLst/>
+            </a:prstGeom>
+          </p:spPr>
+        </p:pic>
+      </p:grpSp>
       <p:sp>
         <p:nvSpPr>
-          <p:cNvPr id="21" name="TextBox 21"/>
+          <p:cNvPr id="12" name="TextBox 12"/>
           <p:cNvSpPr txBox="1"/>
           <p:nvPr/>
         </p:nvSpPr>
         <p:spPr>
           <a:xfrm>
-            <a:off x="908304" y="6400800"/>
-            <a:ext cx="189890" cy="234696"/>
+            <a:off x="755904" y="6413500"/>
+            <a:ext cx="175933" cy="234696"/>
           </a:xfrm>
           <a:prstGeom prst="rect">
             <a:avLst/>
@@ -1727,9 +1354,9 @@
                 <a:solidFill>
                   <a:srgbClr val="5C6570"/>
                 </a:solidFill>
-                <a:latin typeface="+mn-lt"/>
-                <a:ea typeface="+mn-ea"/>
-                <a:cs typeface="+mn-cs"/>
+                <a:latin typeface="+mj-lt"/>
+                <a:ea typeface="+mj-ea"/>
+                <a:cs typeface="+mj-cs"/>
               </a:rPr>
               <a:t>02</a:t>
             </a:r>
@@ -1802,10 +1429,10 @@
         </p:nvGrpSpPr>
         <p:grpSpPr>
           <a:xfrm>
-            <a:off x="899160" y="622300"/>
-            <a:ext cx="7208520" cy="957707"/>
-            <a:chOff x="899160" y="622300"/>
-            <a:chExt cx="7208520" cy="957707"/>
+            <a:off x="899160" y="584200"/>
+            <a:ext cx="8954948" cy="957707"/>
+            <a:chOff x="899160" y="584200"/>
+            <a:chExt cx="8954948" cy="957707"/>
           </a:xfrm>
         </p:grpSpPr>
         <p:sp>
@@ -1816,8 +1443,8 @@
           </p:nvSpPr>
           <p:spPr>
             <a:xfrm>
-              <a:off x="899160" y="622300"/>
-              <a:ext cx="7208520" cy="586740"/>
+              <a:off x="899160" y="584200"/>
+              <a:ext cx="8954948" cy="586740"/>
             </a:xfrm>
             <a:prstGeom prst="rect">
               <a:avLst/>
@@ -1843,7 +1470,7 @@
                   <a:ea typeface="+mn-ea"/>
                   <a:cs typeface="+mn-cs"/>
                 </a:rPr>
-                <a:t>這次試跑：聊天即可產出原生四頁 PPTX</a:t>
+                <a:t>本範本四頁均為可點選的 DrawingML 形狀與文字</a:t>
               </a:r>
             </a:p>
           </p:txBody>
@@ -1856,8 +1483,8 @@
           </p:nvSpPr>
           <p:spPr>
             <a:xfrm>
-              <a:off x="906018" y="1257300"/>
-              <a:ext cx="5841579" cy="322707"/>
+              <a:off x="906018" y="1219200"/>
+              <a:ext cx="6308706" cy="322707"/>
             </a:xfrm>
             <a:prstGeom prst="rect">
               <a:avLst/>
@@ -1883,7 +1510,7 @@
                   <a:ea typeface="+mj-ea"/>
                   <a:cs typeface="+mj-cs"/>
                 </a:rPr>
-                <a:t>This pass: a native four-page PPTX from one Quick Generate run</a:t>
+                <a:t>Every page in this file is selectable DrawingML, not a picture of a slide</a:t>
               </a:r>
             </a:p>
           </p:txBody>
@@ -1897,22 +1524,44 @@
         </p:nvGrpSpPr>
         <p:grpSpPr>
           <a:xfrm>
-            <a:off x="903732" y="2374900"/>
-            <a:ext cx="7249851" cy="767207"/>
-            <a:chOff x="903732" y="2374900"/>
-            <a:chExt cx="7249851" cy="767207"/>
+            <a:off x="914400" y="2222500"/>
+            <a:ext cx="5865484" cy="712470"/>
+            <a:chOff x="914400" y="2222500"/>
+            <a:chExt cx="5865484" cy="712470"/>
           </a:xfrm>
         </p:grpSpPr>
         <p:sp>
           <p:nvSpPr>
-            <p:cNvPr id="6" name="TextBox 6"/>
+            <p:cNvPr id="6" name="Rectangle 6"/>
+            <p:cNvSpPr/>
+            <p:nvPr/>
+          </p:nvSpPr>
+          <p:spPr>
+            <a:xfrm>
+              <a:off x="914400" y="2247900"/>
+              <a:ext cx="76200" cy="457200"/>
+            </a:xfrm>
+            <a:prstGeom prst="rect">
+              <a:avLst/>
+            </a:prstGeom>
+            <a:solidFill>
+              <a:srgbClr val="B8860B"/>
+            </a:solidFill>
+            <a:ln>
+              <a:noFill/>
+            </a:ln>
+          </p:spPr>
+        </p:sp>
+        <p:sp>
+          <p:nvSpPr>
+            <p:cNvPr id="7" name="TextBox 7"/>
             <p:cNvSpPr txBox="1"/>
             <p:nvPr/>
           </p:nvSpPr>
           <p:spPr>
             <a:xfrm>
-              <a:off x="903732" y="2374900"/>
-              <a:ext cx="347857" cy="410718"/>
+              <a:off x="1210056" y="2222500"/>
+              <a:ext cx="5141697" cy="352044"/>
             </a:xfrm>
             <a:prstGeom prst="rect">
               <a:avLst/>
@@ -1930,29 +1579,29 @@
             <a:p>
               <a:pPr algn="l"/>
               <a:r>
-                <a:rPr lang="zh-HK" sz="2100" b="1" dirty="0">
-                  <a:solidFill>
-                    <a:srgbClr val="B8860B"/>
+                <a:rPr lang="zh-HK" sz="1800" b="1" dirty="0">
+                  <a:solidFill>
+                    <a:srgbClr val="123B5C"/>
                   </a:solidFill>
                   <a:latin typeface="+mn-lt"/>
                   <a:ea typeface="+mn-ea"/>
                   <a:cs typeface="+mn-cs"/>
                 </a:rPr>
-                <a:t>01</a:t>
+                <a:t>身份為 Harbour Professional，海軍藍與暖紙</a:t>
               </a:r>
             </a:p>
           </p:txBody>
         </p:sp>
         <p:sp>
           <p:nvSpPr>
-            <p:cNvPr id="7" name="TextBox 7"/>
+            <p:cNvPr id="8" name="TextBox 8"/>
             <p:cNvSpPr txBox="1"/>
             <p:nvPr/>
           </p:nvSpPr>
           <p:spPr>
             <a:xfrm>
-              <a:off x="1589532" y="2374900"/>
-              <a:ext cx="6564051" cy="410718"/>
+              <a:off x="1211580" y="2641600"/>
+              <a:ext cx="5568304" cy="293370"/>
             </a:xfrm>
             <a:prstGeom prst="rect">
               <a:avLst/>
@@ -1970,29 +1619,66 @@
             <a:p>
               <a:pPr algn="l"/>
               <a:r>
-                <a:rPr lang="zh-HK" sz="2100" b="1" dirty="0">
-                  <a:solidFill>
-                    <a:srgbClr val="123B5C"/>
-                  </a:solidFill>
-                  <a:latin typeface="+mn-lt"/>
-                  <a:ea typeface="+mn-ea"/>
-                  <a:cs typeface="+mn-cs"/>
-                </a:rPr>
-                <a:t>身份是 Harbour Professional，不是內地紅金模板</a:t>
+                <a:rPr lang="en-US" sz="1500" dirty="0">
+                  <a:solidFill>
+                    <a:srgbClr val="5C6570"/>
+                  </a:solidFill>
+                  <a:latin typeface="+mj-lt"/>
+                  <a:ea typeface="+mj-ea"/>
+                  <a:cs typeface="+mj-cs"/>
+                </a:rPr>
+                <a:t>Navy, warm paper and JhengHei — not a Mainland SOE chrome set</a:t>
               </a:r>
             </a:p>
           </p:txBody>
         </p:sp>
+      </p:grpSp>
+      <p:grpSp>
+        <p:nvGrpSpPr>
+          <p:cNvPr id="13" name="proof-b"/>
+          <p:cNvGrpSpPr/>
+          <p:nvPr/>
+        </p:nvGrpSpPr>
+        <p:grpSpPr>
+          <a:xfrm>
+            <a:off x="914400" y="3556000"/>
+            <a:ext cx="6430731" cy="712470"/>
+            <a:chOff x="914400" y="3556000"/>
+            <a:chExt cx="6430731" cy="712470"/>
+          </a:xfrm>
+        </p:grpSpPr>
         <p:sp>
           <p:nvSpPr>
-            <p:cNvPr id="8" name="TextBox 8"/>
+            <p:cNvPr id="10" name="Rectangle 10"/>
+            <p:cNvSpPr/>
+            <p:nvPr/>
+          </p:nvSpPr>
+          <p:spPr>
+            <a:xfrm>
+              <a:off x="914400" y="3581400"/>
+              <a:ext cx="76200" cy="457200"/>
+            </a:xfrm>
+            <a:prstGeom prst="rect">
+              <a:avLst/>
+            </a:prstGeom>
+            <a:solidFill>
+              <a:srgbClr val="B8860B"/>
+            </a:solidFill>
+            <a:ln>
+              <a:noFill/>
+            </a:ln>
+          </p:spPr>
+        </p:sp>
+        <p:sp>
+          <p:nvSpPr>
+            <p:cNvPr id="11" name="TextBox 11"/>
             <p:cNvSpPr txBox="1"/>
             <p:nvPr/>
           </p:nvSpPr>
           <p:spPr>
             <a:xfrm>
-              <a:off x="1591818" y="2819400"/>
-              <a:ext cx="5656671" cy="322707"/>
+              <a:off x="1210056" y="3556000"/>
+              <a:ext cx="5120446" cy="352044"/>
             </a:xfrm>
             <a:prstGeom prst="rect">
               <a:avLst/>
@@ -2010,44 +1696,29 @@
             <a:p>
               <a:pPr algn="l"/>
               <a:r>
-                <a:rPr lang="en-US" sz="1650" dirty="0">
-                  <a:solidFill>
-                    <a:srgbClr val="5C6570"/>
-                  </a:solidFill>
-                  <a:latin typeface="+mj-lt"/>
-                  <a:ea typeface="+mj-ea"/>
-                  <a:cs typeface="+mj-cs"/>
-                </a:rPr>
-                <a:t>Navy, warm paper, JhengHei - not a Mainland SOE chrome set</a:t>
+                <a:rPr lang="zh-HK" sz="1800" b="1" dirty="0">
+                  <a:solidFill>
+                    <a:srgbClr val="123B5C"/>
+                  </a:solidFill>
+                  <a:latin typeface="+mn-lt"/>
+                  <a:ea typeface="+mn-ea"/>
+                  <a:cs typeface="+mn-cs"/>
+                </a:rPr>
+                <a:t>語言標籤為 zh-HK，Office 採用香港繁體校對</a:t>
               </a:r>
             </a:p>
           </p:txBody>
         </p:sp>
-      </p:grpSp>
-      <p:grpSp>
-        <p:nvGrpSpPr>
-          <p:cNvPr id="13" name="proof-b"/>
-          <p:cNvGrpSpPr/>
-          <p:nvPr/>
-        </p:nvGrpSpPr>
-        <p:grpSpPr>
-          <a:xfrm>
-            <a:off x="903732" y="3517900"/>
-            <a:ext cx="7352212" cy="767207"/>
-            <a:chOff x="903732" y="3517900"/>
-            <a:chExt cx="7352212" cy="767207"/>
-          </a:xfrm>
-        </p:grpSpPr>
         <p:sp>
           <p:nvSpPr>
-            <p:cNvPr id="10" name="TextBox 10"/>
+            <p:cNvPr id="12" name="TextBox 12"/>
             <p:cNvSpPr txBox="1"/>
             <p:nvPr/>
           </p:nvSpPr>
           <p:spPr>
             <a:xfrm>
-              <a:off x="903732" y="3517900"/>
-              <a:ext cx="347857" cy="410718"/>
+              <a:off x="1211580" y="3975100"/>
+              <a:ext cx="6133551" cy="293370"/>
             </a:xfrm>
             <a:prstGeom prst="rect">
               <a:avLst/>
@@ -2065,29 +1736,66 @@
             <a:p>
               <a:pPr algn="l"/>
               <a:r>
-                <a:rPr lang="zh-HK" sz="2100" b="1" dirty="0">
-                  <a:solidFill>
-                    <a:srgbClr val="B8860B"/>
-                  </a:solidFill>
-                  <a:latin typeface="+mn-lt"/>
-                  <a:ea typeface="+mn-ea"/>
-                  <a:cs typeface="+mn-cs"/>
-                </a:rPr>
-                <a:t>02</a:t>
+                <a:rPr lang="en-US" sz="1500" dirty="0">
+                  <a:solidFill>
+                    <a:srgbClr val="5C6570"/>
+                  </a:solidFill>
+                  <a:latin typeface="+mj-lt"/>
+                  <a:ea typeface="+mj-ea"/>
+                  <a:cs typeface="+mj-cs"/>
+                </a:rPr>
+                <a:t>Deck language is zh-HK so Office proofs Traditional Chinese for Hong Kong</a:t>
               </a:r>
             </a:p>
           </p:txBody>
         </p:sp>
+      </p:grpSp>
+      <p:grpSp>
+        <p:nvGrpSpPr>
+          <p:cNvPr id="17" name="proof-c"/>
+          <p:cNvGrpSpPr/>
+          <p:nvPr/>
+        </p:nvGrpSpPr>
+        <p:grpSpPr>
+          <a:xfrm>
+            <a:off x="914400" y="4889500"/>
+            <a:ext cx="7401893" cy="712470"/>
+            <a:chOff x="914400" y="4889500"/>
+            <a:chExt cx="7401893" cy="712470"/>
+          </a:xfrm>
+        </p:grpSpPr>
         <p:sp>
           <p:nvSpPr>
-            <p:cNvPr id="11" name="TextBox 11"/>
+            <p:cNvPr id="14" name="Rectangle 14"/>
+            <p:cNvSpPr/>
+            <p:nvPr/>
+          </p:nvSpPr>
+          <p:spPr>
+            <a:xfrm>
+              <a:off x="914400" y="4914900"/>
+              <a:ext cx="76200" cy="457200"/>
+            </a:xfrm>
+            <a:prstGeom prst="rect">
+              <a:avLst/>
+            </a:prstGeom>
+            <a:solidFill>
+              <a:srgbClr val="B8860B"/>
+            </a:solidFill>
+            <a:ln>
+              <a:noFill/>
+            </a:ln>
+          </p:spPr>
+        </p:sp>
+        <p:sp>
+          <p:nvSpPr>
+            <p:cNvPr id="15" name="TextBox 15"/>
             <p:cNvSpPr txBox="1"/>
             <p:nvPr/>
           </p:nvSpPr>
           <p:spPr>
             <a:xfrm>
-              <a:off x="1589532" y="3517900"/>
-              <a:ext cx="5691151" cy="410718"/>
+              <a:off x="1210056" y="4889500"/>
+              <a:ext cx="4725135" cy="352044"/>
             </a:xfrm>
             <a:prstGeom prst="rect">
               <a:avLst/>
@@ -2105,7 +1813,7 @@
             <a:p>
               <a:pPr algn="l"/>
               <a:r>
-                <a:rPr lang="zh-HK" sz="2100" b="1" dirty="0">
+                <a:rPr lang="zh-HK" sz="1800" b="1" dirty="0">
                   <a:solidFill>
                     <a:srgbClr val="123B5C"/>
                   </a:solidFill>
@@ -2113,21 +1821,21 @@
                   <a:ea typeface="+mn-ea"/>
                   <a:cs typeface="+mn-cs"/>
                 </a:rPr>
-                <a:t>語言標籤是 zh-HK，Office 走香港繁體校對</a:t>
+                <a:t>輸出可在 PowerPoint 續改，無需重做截圖</a:t>
               </a:r>
             </a:p>
           </p:txBody>
         </p:sp>
         <p:sp>
           <p:nvSpPr>
-            <p:cNvPr id="12" name="TextBox 12"/>
+            <p:cNvPr id="16" name="TextBox 16"/>
             <p:cNvSpPr txBox="1"/>
             <p:nvPr/>
           </p:nvSpPr>
           <p:spPr>
             <a:xfrm>
-              <a:off x="1591818" y="3962400"/>
-              <a:ext cx="6664126" cy="322707"/>
+              <a:off x="1211580" y="5308600"/>
+              <a:ext cx="7104713" cy="293370"/>
             </a:xfrm>
             <a:prstGeom prst="rect">
               <a:avLst/>
@@ -2145,7 +1853,7 @@
             <a:p>
               <a:pPr algn="l"/>
               <a:r>
-                <a:rPr lang="en-US" sz="1650" dirty="0">
+                <a:rPr lang="en-US" sz="1500" dirty="0">
                   <a:solidFill>
                     <a:srgbClr val="5C6570"/>
                   </a:solidFill>
@@ -2153,142 +1861,7 @@
                   <a:ea typeface="+mj-ea"/>
                   <a:cs typeface="+mj-cs"/>
                 </a:rPr>
-                <a:t>Deck language zh-HK so proofing and East-Asian fonts land on Hong Kong</a:t>
-              </a:r>
-            </a:p>
-          </p:txBody>
-        </p:sp>
-      </p:grpSp>
-      <p:grpSp>
-        <p:nvGrpSpPr>
-          <p:cNvPr id="17" name="proof-c"/>
-          <p:cNvGrpSpPr/>
-          <p:nvPr/>
-        </p:nvGrpSpPr>
-        <p:grpSpPr>
-          <a:xfrm>
-            <a:off x="903732" y="4660900"/>
-            <a:ext cx="7329265" cy="767207"/>
-            <a:chOff x="903732" y="4660900"/>
-            <a:chExt cx="7329265" cy="767207"/>
-          </a:xfrm>
-        </p:grpSpPr>
-        <p:sp>
-          <p:nvSpPr>
-            <p:cNvPr id="14" name="TextBox 14"/>
-            <p:cNvSpPr txBox="1"/>
-            <p:nvPr/>
-          </p:nvSpPr>
-          <p:spPr>
-            <a:xfrm>
-              <a:off x="903732" y="4660900"/>
-              <a:ext cx="347857" cy="410718"/>
-            </a:xfrm>
-            <a:prstGeom prst="rect">
-              <a:avLst/>
-            </a:prstGeom>
-            <a:noFill/>
-            <a:ln>
-              <a:noFill/>
-            </a:ln>
-          </p:spPr>
-          <p:txBody>
-            <a:bodyPr wrap="none" lIns="0" tIns="0" rIns="0" bIns="0" anchor="t" anchorCtr="0">
-              <a:spAutoFit/>
-            </a:bodyPr>
-            <a:lstStyle/>
-            <a:p>
-              <a:pPr algn="l"/>
-              <a:r>
-                <a:rPr lang="zh-HK" sz="2100" b="1" dirty="0">
-                  <a:solidFill>
-                    <a:srgbClr val="B8860B"/>
-                  </a:solidFill>
-                  <a:latin typeface="+mn-lt"/>
-                  <a:ea typeface="+mn-ea"/>
-                  <a:cs typeface="+mn-cs"/>
-                </a:rPr>
-                <a:t>03</a:t>
-              </a:r>
-            </a:p>
-          </p:txBody>
-        </p:sp>
-        <p:sp>
-          <p:nvSpPr>
-            <p:cNvPr id="15" name="TextBox 15"/>
-            <p:cNvSpPr txBox="1"/>
-            <p:nvPr/>
-          </p:nvSpPr>
-          <p:spPr>
-            <a:xfrm>
-              <a:off x="1589532" y="4660900"/>
-              <a:ext cx="6643465" cy="410718"/>
-            </a:xfrm>
-            <a:prstGeom prst="rect">
-              <a:avLst/>
-            </a:prstGeom>
-            <a:noFill/>
-            <a:ln>
-              <a:noFill/>
-            </a:ln>
-          </p:spPr>
-          <p:txBody>
-            <a:bodyPr wrap="none" lIns="0" tIns="0" rIns="0" bIns="0" anchor="t" anchorCtr="0">
-              <a:spAutoFit/>
-            </a:bodyPr>
-            <a:lstStyle/>
-            <a:p>
-              <a:pPr algn="l"/>
-              <a:r>
-                <a:rPr lang="zh-HK" sz="2100" b="1" dirty="0">
-                  <a:solidFill>
-                    <a:srgbClr val="123B5C"/>
-                  </a:solidFill>
-                  <a:latin typeface="+mn-lt"/>
-                  <a:ea typeface="+mn-ea"/>
-                  <a:cs typeface="+mn-cs"/>
-                </a:rPr>
-                <a:t>輸出是可點選的形狀與文字，可在 PowerPoint 續改</a:t>
-              </a:r>
-            </a:p>
-          </p:txBody>
-        </p:sp>
-        <p:sp>
-          <p:nvSpPr>
-            <p:cNvPr id="16" name="TextBox 16"/>
-            <p:cNvSpPr txBox="1"/>
-            <p:nvPr/>
-          </p:nvSpPr>
-          <p:spPr>
-            <a:xfrm>
-              <a:off x="1591818" y="5105400"/>
-              <a:ext cx="6129900" cy="322707"/>
-            </a:xfrm>
-            <a:prstGeom prst="rect">
-              <a:avLst/>
-            </a:prstGeom>
-            <a:noFill/>
-            <a:ln>
-              <a:noFill/>
-            </a:ln>
-          </p:spPr>
-          <p:txBody>
-            <a:bodyPr wrap="none" lIns="0" tIns="0" rIns="0" bIns="0" anchor="t" anchorCtr="0">
-              <a:spAutoFit/>
-            </a:bodyPr>
-            <a:lstStyle/>
-            <a:p>
-              <a:pPr algn="l"/>
-              <a:r>
-                <a:rPr lang="en-US" sz="1650" dirty="0">
-                  <a:solidFill>
-                    <a:srgbClr val="5C6570"/>
-                  </a:solidFill>
-                  <a:latin typeface="+mj-lt"/>
-                  <a:ea typeface="+mj-ea"/>
-                  <a:cs typeface="+mj-cs"/>
-                </a:rPr>
-                <a:t>Export is native shapes and text you can keep editing in PowerPoint</a:t>
+                <a:t>The export stays editable in PowerPoint; it does not need to be rebuilt as a screenshot</a:t>
               </a:r>
             </a:p>
           </p:txBody>
@@ -2302,8 +1875,8 @@
         </p:nvSpPr>
         <p:spPr>
           <a:xfrm>
-            <a:off x="908304" y="6400800"/>
-            <a:ext cx="189890" cy="234696"/>
+            <a:off x="908304" y="6413500"/>
+            <a:ext cx="175933" cy="234696"/>
           </a:xfrm>
           <a:prstGeom prst="rect">
             <a:avLst/>
@@ -2325,9 +1898,9 @@
                 <a:solidFill>
                   <a:srgbClr val="5C6570"/>
                 </a:solidFill>
-                <a:latin typeface="+mn-lt"/>
-                <a:ea typeface="+mn-ea"/>
-                <a:cs typeface="+mn-cs"/>
+                <a:latin typeface="+mj-lt"/>
+                <a:ea typeface="+mj-ea"/>
+                <a:cs typeface="+mj-cs"/>
               </a:rPr>
               <a:t>03</a:t>
             </a:r>
@@ -2378,8 +1951,8 @@
         </p:nvSpPr>
         <p:spPr>
           <a:xfrm>
-            <a:off x="914400" y="1790700"/>
-            <a:ext cx="76200" cy="2095500"/>
+            <a:off x="914400" y="1676400"/>
+            <a:ext cx="76200" cy="2667000"/>
           </a:xfrm>
           <a:prstGeom prst="rect">
             <a:avLst/>
@@ -2400,10 +1973,10 @@
         </p:nvGrpSpPr>
         <p:grpSpPr>
           <a:xfrm>
-            <a:off x="1213104" y="1022350"/>
-            <a:ext cx="1235035" cy="234696"/>
-            <a:chOff x="1213104" y="1022350"/>
-            <a:chExt cx="1235035" cy="234696"/>
+            <a:off x="1213104" y="965200"/>
+            <a:ext cx="1256824" cy="234696"/>
+            <a:chOff x="1213104" y="965200"/>
+            <a:chExt cx="1256824" cy="234696"/>
           </a:xfrm>
         </p:grpSpPr>
         <p:sp>
@@ -2414,8 +1987,8 @@
           </p:nvSpPr>
           <p:spPr>
             <a:xfrm>
-              <a:off x="1213104" y="1022350"/>
-              <a:ext cx="1235035" cy="234696"/>
+              <a:off x="1213104" y="965200"/>
+              <a:ext cx="1256824" cy="234696"/>
             </a:xfrm>
             <a:prstGeom prst="rect">
               <a:avLst/>
@@ -2433,7 +2006,7 @@
             <a:p>
               <a:pPr algn="l"/>
               <a:r>
-                <a:rPr lang="en-US" sz="1200" dirty="0">
+                <a:rPr lang="zh-HK" sz="1200" dirty="0">
                   <a:solidFill>
                     <a:srgbClr val="D5D0C8"/>
                   </a:solidFill>
@@ -2441,7 +2014,7 @@
                   <a:ea typeface="+mj-ea"/>
                   <a:cs typeface="+mj-cs"/>
                 </a:rPr>
-                <a:t>NEXT STEP | Q&amp;A</a:t>
+                <a:t>建議 · 下次會議前</a:t>
               </a:r>
             </a:p>
           </p:txBody>
@@ -2449,16 +2022,16 @@
       </p:grpSp>
       <p:grpSp>
         <p:nvGrpSpPr>
-          <p:cNvPr id="7" name="ask-title"/>
+          <p:cNvPr id="6" name="ask-title"/>
           <p:cNvGrpSpPr/>
           <p:nvPr/>
         </p:nvGrpSpPr>
         <p:grpSpPr>
           <a:xfrm>
-            <a:off x="1203960" y="2032000"/>
-            <a:ext cx="7875224" cy="1033907"/>
-            <a:chOff x="1203960" y="2032000"/>
-            <a:chExt cx="7875224" cy="1033907"/>
+            <a:off x="1203960" y="1917700"/>
+            <a:ext cx="7612380" cy="586740"/>
+            <a:chOff x="1203960" y="1917700"/>
+            <a:chExt cx="7612380" cy="586740"/>
           </a:xfrm>
         </p:grpSpPr>
         <p:sp>
@@ -2469,8 +2042,8 @@
           </p:nvSpPr>
           <p:spPr>
             <a:xfrm>
-              <a:off x="1203960" y="2032000"/>
-              <a:ext cx="7875224" cy="586740"/>
+              <a:off x="1203960" y="1917700"/>
+              <a:ext cx="7612380" cy="586740"/>
             </a:xfrm>
             <a:prstGeom prst="rect">
               <a:avLst/>
@@ -2496,21 +2069,47 @@
                   <a:ea typeface="+mn-ea"/>
                   <a:cs typeface="+mn-cs"/>
                 </a:rPr>
-                <a:t>下一步：在本機 PowerPoint 打開這份檔案</a:t>
+                <a:t>請於下次會議前以本範本產出</a:t>
+              </a:r>
+              <a:r>
+                <a:rPr lang="zh-HK" sz="3000" b="1" dirty="0">
+                  <a:solidFill>
+                    <a:srgbClr val="B8860B"/>
+                  </a:solidFill>
+                  <a:latin typeface="+mn-lt"/>
+                  <a:ea typeface="+mn-ea"/>
+                  <a:cs typeface="+mn-cs"/>
+                </a:rPr>
+                <a:t>可編輯 PPTX</a:t>
               </a:r>
             </a:p>
           </p:txBody>
         </p:sp>
+      </p:grpSp>
+      <p:grpSp>
+        <p:nvGrpSpPr>
+          <p:cNvPr id="8" name="ask-support"/>
+          <p:cNvGrpSpPr/>
+          <p:nvPr/>
+        </p:nvGrpSpPr>
+        <p:grpSpPr>
+          <a:xfrm>
+            <a:off x="1210818" y="2781300"/>
+            <a:ext cx="7488715" cy="322707"/>
+            <a:chOff x="1210818" y="2781300"/>
+            <a:chExt cx="7488715" cy="322707"/>
+          </a:xfrm>
+        </p:grpSpPr>
         <p:sp>
           <p:nvSpPr>
-            <p:cNvPr id="6" name="TextBox 6"/>
+            <p:cNvPr id="7" name="TextBox 7"/>
             <p:cNvSpPr txBox="1"/>
             <p:nvPr/>
           </p:nvSpPr>
           <p:spPr>
             <a:xfrm>
-              <a:off x="1210818" y="2743200"/>
-              <a:ext cx="5388605" cy="322707"/>
+              <a:off x="1210818" y="2781300"/>
+              <a:ext cx="7488715" cy="322707"/>
             </a:xfrm>
             <a:prstGeom prst="rect">
               <a:avLst/>
@@ -2536,7 +2135,7 @@
                   <a:ea typeface="+mj-ea"/>
                   <a:cs typeface="+mj-cs"/>
                 </a:rPr>
-                <a:t>Open the exported PPTX on your machine and keep editing</a:t>
+                <a:t>Please issue the next committee pack as an editable PPTX before the next meeting</a:t>
               </a:r>
             </a:p>
           </p:txBody>
@@ -2550,22 +2149,22 @@
         </p:nvGrpSpPr>
         <p:grpSpPr>
           <a:xfrm>
-            <a:off x="1208532" y="3657600"/>
-            <a:ext cx="6575126" cy="1389507"/>
-            <a:chOff x="1208532" y="3657600"/>
-            <a:chExt cx="6575126" cy="1389507"/>
+            <a:off x="1210056" y="3517900"/>
+            <a:ext cx="5618988" cy="1114044"/>
+            <a:chOff x="1210056" y="3517900"/>
+            <a:chExt cx="5618988" cy="1114044"/>
           </a:xfrm>
         </p:grpSpPr>
         <p:sp>
           <p:nvSpPr>
-            <p:cNvPr id="8" name="TextBox 8"/>
+            <p:cNvPr id="9" name="TextBox 9"/>
             <p:cNvSpPr txBox="1"/>
             <p:nvPr/>
           </p:nvSpPr>
           <p:spPr>
             <a:xfrm>
-              <a:off x="1208532" y="3657600"/>
-              <a:ext cx="5515356" cy="867918"/>
+              <a:off x="1210056" y="3517900"/>
+              <a:ext cx="5618988" cy="1114044"/>
             </a:xfrm>
             <a:prstGeom prst="rect">
               <a:avLst/>
@@ -2583,11 +2182,11 @@
             <a:p>
               <a:pPr algn="l">
                 <a:lnSpc>
-                  <a:spcPts val="3600"/>
+                  <a:spcPts val="3000"/>
                 </a:lnSpc>
               </a:pPr>
               <a:r>
-                <a:rPr lang="zh-HK" sz="2100" dirty="0">
+                <a:rPr lang="zh-HK" sz="1800" dirty="0">
                   <a:solidFill>
                     <a:srgbClr val="FFFFFF"/>
                   </a:solidFill>
@@ -2595,10 +2194,10 @@
                   <a:ea typeface="+mn-ea"/>
                   <a:cs typeface="+mn-cs"/>
                 </a:rPr>
-                <a:t>檔案在 projects/.../exports/ 目錄。</a:t>
+                <a:t>建議秘書處於下次會議前，按本範本產出可編輯 PPTX。</a:t>
               </a:r>
               <a:br>
-                <a:rPr lang="zh-HK" sz="2100" dirty="0">
+                <a:rPr lang="zh-HK" sz="1800" dirty="0">
                   <a:solidFill>
                     <a:srgbClr val="FFFFFF"/>
                   </a:solidFill>
@@ -2608,7 +2207,7 @@
                 </a:rPr>
               </a:br>
               <a:r>
-                <a:rPr lang="zh-HK" sz="2100" dirty="0">
+                <a:rPr lang="zh-HK" sz="1800" dirty="0">
                   <a:solidFill>
                     <a:srgbClr val="FFFFFF"/>
                   </a:solidFill>
@@ -2616,47 +2215,28 @@
                   <a:ea typeface="+mn-ea"/>
                   <a:cs typeface="+mn-cs"/>
                 </a:rPr>
-                <a:t>之後的真實簡報，回到 Cursor IDE 再跑一次。</a:t>
-              </a:r>
-            </a:p>
-          </p:txBody>
-        </p:sp>
-        <p:sp>
-          <p:nvSpPr>
-            <p:cNvPr id="9" name="TextBox 9"/>
-            <p:cNvSpPr txBox="1"/>
-            <p:nvPr/>
-          </p:nvSpPr>
-          <p:spPr>
-            <a:xfrm>
-              <a:off x="1210818" y="4724400"/>
-              <a:ext cx="6572840" cy="322707"/>
-            </a:xfrm>
-            <a:prstGeom prst="rect">
-              <a:avLst/>
-            </a:prstGeom>
-            <a:noFill/>
-            <a:ln>
-              <a:noFill/>
-            </a:ln>
-          </p:spPr>
-          <p:txBody>
-            <a:bodyPr wrap="none" lIns="0" tIns="0" rIns="0" bIns="0" anchor="t" anchorCtr="0">
-              <a:spAutoFit/>
-            </a:bodyPr>
-            <a:lstStyle/>
-            <a:p>
-              <a:pPr algn="l"/>
-              <a:r>
-                <a:rPr lang="en-US" sz="1650" dirty="0">
-                  <a:solidFill>
-                    <a:srgbClr val="D5D0C8"/>
-                  </a:solidFill>
-                  <a:latin typeface="+mj-lt"/>
-                  <a:ea typeface="+mj-ea"/>
-                  <a:cs typeface="+mj-cs"/>
-                </a:rPr>
-                <a:t>File lives under projects/.../exports/. Real decks: run again in Cursor IDE.</a:t>
+                <a:t>檔案共四頁，限時八分鐘。</a:t>
+              </a:r>
+              <a:br>
+                <a:rPr lang="zh-HK" sz="1800" dirty="0">
+                  <a:solidFill>
+                    <a:srgbClr val="FFFFFF"/>
+                  </a:solidFill>
+                  <a:latin typeface="+mn-lt"/>
+                  <a:ea typeface="+mn-ea"/>
+                  <a:cs typeface="+mn-cs"/>
+                </a:rPr>
+              </a:br>
+              <a:r>
+                <a:rPr lang="zh-HK" sz="1800" dirty="0">
+                  <a:solidFill>
+                    <a:srgbClr val="FFFFFF"/>
+                  </a:solidFill>
+                  <a:latin typeface="+mn-lt"/>
+                  <a:ea typeface="+mn-ea"/>
+                  <a:cs typeface="+mn-cs"/>
+                </a:rPr>
+                <a:t>自 28 October 2026 起作為委員會文件的交付標準。</a:t>
               </a:r>
             </a:p>
           </p:txBody>
@@ -2670,8 +2250,8 @@
         </p:nvSpPr>
         <p:spPr>
           <a:xfrm>
-            <a:off x="1213104" y="6248400"/>
-            <a:ext cx="189890" cy="234696"/>
+            <a:off x="1213104" y="6184900"/>
+            <a:ext cx="175933" cy="234696"/>
           </a:xfrm>
           <a:prstGeom prst="rect">
             <a:avLst/>
@@ -2693,9 +2273,9 @@
                 <a:solidFill>
                   <a:srgbClr val="D5D0C8"/>
                 </a:solidFill>
-                <a:latin typeface="+mn-lt"/>
-                <a:ea typeface="+mn-ea"/>
-                <a:cs typeface="+mn-cs"/>
+                <a:latin typeface="+mj-lt"/>
+                <a:ea typeface="+mj-ea"/>
+                <a:cs typeface="+mj-cs"/>
               </a:rPr>
               <a:t>04</a:t>
             </a:r>
@@ -2714,9 +2294,9 @@
 </file>
 
 <file path=ppt/theme/theme1.xml><?xml version="1.0" encoding="utf-8"?>
-<a:theme xmlns:a="http://schemas.openxmlformats.org/drawingml/2006/main" name="ai_native_pptx_brief">
+<a:theme xmlns:a="http://schemas.openxmlformats.org/drawingml/2006/main" name="hk_native_pptx_brief">
   <a:themeElements>
-    <a:clrScheme name="ai_native_pptx_brief">
+    <a:clrScheme name="hk_native_pptx_brief">
       <a:dk1>
         <a:sysClr val="windowText" lastClr="000000"/>
       </a:dk1>
@@ -2754,7 +2334,7 @@
         <a:srgbClr val="800080"/>
       </a:folHlink>
     </a:clrScheme>
-    <a:fontScheme name="ai_native_pptx_brief">
+    <a:fontScheme name="hk_native_pptx_brief">
       <a:majorFont>
         <a:latin typeface="Calibri"/>
         <a:ea typeface="Microsoft JhengHei"/>
@@ -2826,7 +2406,7 @@
         <a:font script="Geor" typeface="Sylfaen"/>
       </a:minorFont>
     </a:fontScheme>
-    <a:fmtScheme name="ai_native_pptx_brief">
+    <a:fmtScheme name="hk_native_pptx_brief">
       <a:fillStyleLst>
         <a:solidFill>
           <a:schemeClr val="phClr"/>

</xml_diff>

<commit_message>
feat(templates): keep Style method language off generated slide copy
Harbour Professional Voice now owns a method-is-not-copy rule and reject
rows for the leaked BLUF slogans. Styles and docs point at that owner.
The committee-paper example is rewritten as announcement copy.

Co-authored-by: Charliech <charleschtsoi@gmail.com>
</commit_message>
<xml_diff>
--- a/examples/ai_native_pptx_brief.pptx
+++ b/examples/ai_native_pptx_brief.pptx
@@ -711,9 +711,9 @@
         <p:grpSpPr>
           <a:xfrm>
             <a:off x="1200150" y="1879600"/>
-            <a:ext cx="6972300" cy="1409700"/>
+            <a:ext cx="6291262" cy="1409700"/>
             <a:chOff x="1200150" y="1879600"/>
-            <a:chExt cx="6972300" cy="1409700"/>
+            <a:chExt cx="6291262" cy="1409700"/>
           </a:xfrm>
         </p:grpSpPr>
         <p:sp>
@@ -725,7 +725,7 @@
           <p:spPr>
             <a:xfrm>
               <a:off x="1200150" y="1879600"/>
-              <a:ext cx="6972300" cy="1409700"/>
+              <a:ext cx="6291262" cy="1409700"/>
             </a:xfrm>
             <a:prstGeom prst="rect">
               <a:avLst/>
@@ -755,7 +755,7 @@
                   <a:ea typeface="+mn-ea"/>
                   <a:cs typeface="+mn-cs"/>
                 </a:rPr>
-                <a:t>建議以</a:t>
+                <a:t>建議委員會採用</a:t>
               </a:r>
               <a:r>
                 <a:rPr lang="zh-HK" sz="3900" b="1" dirty="0">
@@ -787,7 +787,7 @@
                   <a:ea typeface="+mn-ea"/>
                   <a:cs typeface="+mn-cs"/>
                 </a:rPr>
-                <a:t>作為本港委員會文件的交付標準</a:t>
+                <a:t>作為本港文件的交付標準</a:t>
               </a:r>
             </a:p>
           </p:txBody>
@@ -802,9 +802,9 @@
         <p:grpSpPr>
           <a:xfrm>
             <a:off x="1210818" y="3771900"/>
-            <a:ext cx="5608012" cy="322707"/>
+            <a:ext cx="6326979" cy="322707"/>
             <a:chOff x="1210818" y="3771900"/>
-            <a:chExt cx="5608012" cy="322707"/>
+            <a:chExt cx="6326979" cy="322707"/>
           </a:xfrm>
         </p:grpSpPr>
         <p:sp>
@@ -816,7 +816,7 @@
           <p:spPr>
             <a:xfrm>
               <a:off x="1210818" y="3771900"/>
-              <a:ext cx="5608012" cy="322707"/>
+              <a:ext cx="6326979" cy="322707"/>
             </a:xfrm>
             <a:prstGeom prst="rect">
               <a:avLst/>
@@ -842,7 +842,7 @@
                   <a:ea typeface="+mj-ea"/>
                   <a:cs typeface="+mj-cs"/>
                 </a:rPr>
-                <a:t>Committee papers should leave the room as an editable PPTX</a:t>
+                <a:t>Recommend the Committee adopt editable PPTX as the paper format</a:t>
               </a:r>
             </a:p>
           </p:txBody>
@@ -1049,7 +1049,7 @@
           <p:spPr>
             <a:xfrm>
               <a:off x="754380" y="1739900"/>
-              <a:ext cx="3285096" cy="560070"/>
+              <a:ext cx="3355315" cy="560070"/>
             </a:xfrm>
             <a:prstGeom prst="rect">
               <a:avLst/>
@@ -1079,7 +1079,7 @@
                   <a:ea typeface="+mj-ea"/>
                   <a:cs typeface="+mj-cs"/>
                 </a:rPr>
-                <a:t>A screenshot cannot take the committee's</a:t>
+                <a:t>Screenshot files cannot be revised to the</a:t>
               </a:r>
               <a:br>
                 <a:rPr lang="en-US" sz="1500" dirty="0">
@@ -1100,7 +1100,7 @@
                   <a:ea typeface="+mj-ea"/>
                   <a:cs typeface="+mj-cs"/>
                 </a:rPr>
-                <a:t>amendments after the meeting</a:t>
+                <a:t>Committee's instructions after the meeting</a:t>
               </a:r>
             </a:p>
           </p:txBody>
@@ -1525,9 +1525,9 @@
         <p:grpSpPr>
           <a:xfrm>
             <a:off x="914400" y="2222500"/>
-            <a:ext cx="5865484" cy="712470"/>
+            <a:ext cx="6199151" cy="712470"/>
             <a:chOff x="914400" y="2222500"/>
-            <a:chExt cx="5865484" cy="712470"/>
+            <a:chExt cx="6199151" cy="712470"/>
           </a:xfrm>
         </p:grpSpPr>
         <p:sp>
@@ -1601,7 +1601,7 @@
           <p:spPr>
             <a:xfrm>
               <a:off x="1211580" y="2641600"/>
-              <a:ext cx="5568304" cy="293370"/>
+              <a:ext cx="5901971" cy="293370"/>
             </a:xfrm>
             <a:prstGeom prst="rect">
               <a:avLst/>
@@ -1627,7 +1627,7 @@
                   <a:ea typeface="+mj-ea"/>
                   <a:cs typeface="+mj-cs"/>
                 </a:rPr>
-                <a:t>Navy, warm paper and JhengHei — not a Mainland SOE chrome set</a:t>
+                <a:t>Harbour navy and warm paper — not a Mainland government template</a:t>
               </a:r>
             </a:p>
           </p:txBody>
@@ -1642,9 +1642,9 @@
         <p:grpSpPr>
           <a:xfrm>
             <a:off x="914400" y="3556000"/>
-            <a:ext cx="6430731" cy="712470"/>
+            <a:ext cx="6135658" cy="712470"/>
             <a:chOff x="914400" y="3556000"/>
-            <a:chExt cx="6430731" cy="712470"/>
+            <a:chExt cx="6135658" cy="712470"/>
           </a:xfrm>
         </p:grpSpPr>
         <p:sp>
@@ -1718,7 +1718,7 @@
           <p:spPr>
             <a:xfrm>
               <a:off x="1211580" y="3975100"/>
-              <a:ext cx="6133551" cy="293370"/>
+              <a:ext cx="5838478" cy="293370"/>
             </a:xfrm>
             <a:prstGeom prst="rect">
               <a:avLst/>
@@ -1744,7 +1744,7 @@
                   <a:ea typeface="+mj-ea"/>
                   <a:cs typeface="+mj-cs"/>
                 </a:rPr>
-                <a:t>Deck language is zh-HK so Office proofs Traditional Chinese for Hong Kong</a:t>
+                <a:t>The file uses zh-HK, so Office proofs Traditional Chinese for Hong Kong</a:t>
               </a:r>
             </a:p>
           </p:txBody>
@@ -1759,9 +1759,9 @@
         <p:grpSpPr>
           <a:xfrm>
             <a:off x="914400" y="4889500"/>
-            <a:ext cx="7401893" cy="712470"/>
+            <a:ext cx="7542877" cy="712470"/>
             <a:chOff x="914400" y="4889500"/>
-            <a:chExt cx="7401893" cy="712470"/>
+            <a:chExt cx="7542877" cy="712470"/>
           </a:xfrm>
         </p:grpSpPr>
         <p:sp>
@@ -1835,7 +1835,7 @@
           <p:spPr>
             <a:xfrm>
               <a:off x="1211580" y="5308600"/>
-              <a:ext cx="7104713" cy="293370"/>
+              <a:ext cx="7245697" cy="293370"/>
             </a:xfrm>
             <a:prstGeom prst="rect">
               <a:avLst/>
@@ -1861,7 +1861,7 @@
                   <a:ea typeface="+mj-ea"/>
                   <a:cs typeface="+mj-cs"/>
                 </a:rPr>
-                <a:t>The export stays editable in PowerPoint; it does not need to be rebuilt as a screenshot</a:t>
+                <a:t>The export stays editable in PowerPoint and does not need to be rebuilt as a screenshot</a:t>
               </a:r>
             </a:p>
           </p:txBody>
@@ -2236,7 +2236,7 @@
                   <a:ea typeface="+mn-ea"/>
                   <a:cs typeface="+mn-cs"/>
                 </a:rPr>
-                <a:t>自 28 October 2026 起作為委員會文件的交付標準。</a:t>
+                <a:t>自 2026 年 10 月 28 日起作為委員會文件的交付標準。</a:t>
               </a:r>
             </a:p>
           </p:txBody>

</xml_diff>